<commit_message>
Revise LaunchMinds deck to foreground Minds as the underlying platform
Rewrote script and slides for a Minds/Minds-community audience: leads
with the Launch+Minds name story, splits positioning into Harness
(context layer) vs Minds (model layer), and reframes stage 3's
per-project "Minds" as literal Minds model instances coordinating in
a plan/execute/analyze/adjust loop, rather than a generic role label.

Co-Authored-By: Claude Sonnet 5 <noreply@anthropic.com>
Co-Authored-By: Claude Fable 5 <noreply@anthropic.com>
</commit_message>
<xml_diff>
--- a/presentations/launchminds-agent-evolution-2026-08/launchminds-deck.pptx
+++ b/presentations/launchminds-agent-evolution-2026-08/launchminds-deck.pptx
@@ -510,7 +510,7 @@
           <a:lstStyle/>
           <a:p>
             <a:r>
-              <a:t>Thanks everyone. Today I want to walk you through LaunchMinds — not just what it does, but how it's evolving, and where it's headed next. Our founding idea has always been simple: don't give brands a better tool to run campaigns — have AI figure out the campaign strategy for them. Everything we've built follows from that one line.</a:t>
+              <a:t>Good [morning/afternoon] — I'm here to show you what we've built on top of Minds. Our name isn't an accident: Launch, plus Minds. We picked it because Minds is the foundation everything we do stands on — the same role Claude or GPT-4 plays for other companies, Minds plays for us. What you'll see today is proof of what that foundation makes possible, and where we want to take it next, together.</a:t>
             </a:r>
           </a:p>
         </p:txBody>
@@ -580,7 +580,7 @@
           <a:lstStyle/>
           <a:p>
             <a:r>
-              <a:t>Anyone who's run a brand campaign knows the pain. You're juggling five tools to plan it, another few to launch it across Twitter, Discord, Telegram, on-chain — and then performance data sits in a spreadsheet nobody revisits. There's no loop. Every campaign starts from scratch. That's the gap we built LaunchMinds to close.</a:t>
+              <a:t>Brand marketing today is stitched together by hand — one tool for campaign design, another for deployment, a spreadsheet for resource orchestration, and a person holding it all in their head. That doesn't scale, and it doesn't get smarter over time. We don't think the fix is another point tool. It's a system that reasons across the entire lifecycle — and that requires real intelligence at the core, not automation scripts with an AI label on them.</a:t>
             </a:r>
           </a:p>
         </p:txBody>
@@ -650,7 +650,7 @@
           <a:lstStyle/>
           <a:p>
             <a:r>
-              <a:t>Here's how we describe ourselves today: LaunchMinds is an AI-native, end-to-end brand marketing platform that leverages Harness to build proprietary enterprise contexts — automating the entire lifecycle from campaign design and multi-platform deployment to resource orchestration. In plain terms: we turn a messy marketing problem into a structured, actionable workflow, and that workflow is what drives scalable growth. Harness is the core of that — it's how we build a persistent, proprietary understanding of a brand, and everything downstream runs on top of it.</a:t>
+              <a:t>[read core line]. Two things are doing the work here, and they're worth separating for this room. Harness is our layer — the proprietary context and memory that make a plan actually understand a specific brand, a specific market, a specific history of what's worked before. Minds is what Harness runs on — the model layer, the actual reasoning underneath every plan we generate. Harness without Minds is just a database. Minds without Harness is generic. Together, that's what makes this Minds-driven, not just Minds-adjacent.</a:t>
             </a:r>
           </a:p>
         </p:txBody>
@@ -720,7 +720,7 @@
           <a:lstStyle/>
           <a:p>
             <a:r>
-              <a:t>To explain where LaunchMinds is headed, I want to borrow an analogy from something we all live in daily: how AI-assisted coding has evolved. It went through three distinct stages — and LaunchMinds is climbing that same ladder, one rung behind but on the same trajectory. Let's walk through it.</a:t>
+              <a:t>If you've watched how coding assistants evolved, you've seen this arc: first, assisted completion — suggestions, not action. Then single-session execution — an agent that completes a full task in one sitting, with a human watching. Then true agent mode — long-running, autonomous, checking its own work. We're building LaunchMinds through that same three-stage arc, applied to brand marketing instead of code. And because we built it Minds-native from the start, each stage is a Minds workflow — not a script with a model bolted on.</a:t>
             </a:r>
           </a:p>
         </p:txBody>
@@ -790,7 +790,7 @@
           <a:lstStyle/>
           <a:p>
             <a:r>
-              <a:t>Stage one in coding was inline completion — tools like early Copilot suggesting the next few lines while a human still drove the whole thing. That was LaunchMinds' starting point too. Our AI helped generate campaign content — task descriptions, narrative copy — but a person still designed the strategy and assembled every piece by hand. Useful, but narrow.</a:t>
+              <a:t>Stage one is done and live. This is assisted completion — Minds helping a human draft a campaign: proposing structure, pulling in context Harness has stored, drafting copy. The human stays in the loop at every step. It's the smallest, safest version of Minds-driven work, and it's already saving our team real hours today.</a:t>
             </a:r>
           </a:p>
         </p:txBody>
@@ -860,7 +860,7 @@
           <a:lstStyle/>
           <a:p>
             <a:r>
-              <a:t>Stage two in coding is where a single session can take a full task description and just execute it, start to finish, in one sitting. That's exactly where LaunchMinds is right now. Today, one session handles project registration, campaign strategy planning, and deployment to the platform — all in one pass. It's powered by our internal skill system, which encodes the entire campaign schema and workflow, so we go from a brief to a live campaign without switching tools or people. This is shipped. This is real, working today.</a:t>
+              <a:t>Stage two is what's running in production right now. One session, one Mind, handling registration, planning, and deployment end to end — no handoffs between tools. It runs through our internal skill system, which is essentially a set of structured capabilities we hand to Minds so it can act, not just suggest. This is the first stage where Minds does real work autonomously within a session, and it's in daily use today.</a:t>
             </a:r>
           </a:p>
         </p:txBody>
@@ -930,7 +930,7 @@
           <a:lstStyle/>
           <a:p>
             <a:r>
-              <a:t>Stage three in coding is agent mode — not one bounded session, but a persistent system of multiple agents, each with a role, coordinating over time. That's the milestone we're now chasing. We're building a persistent workspace for every project, seeded by Harness — our proprietary brand context. Inside it, multiple 'Minds' divide the labor: one plans the marketing strategy, one executes and deploys it, one analyzes how the campaign actually performed, and one feeds that analysis back into the next round's plan. Not one-shot — a continuous, self-improving loop.</a:t>
+              <a:t>Stage three is our next milestone, and it's the part I think matters most for this room. We're building a per-project workspace where multiple Minds instances run side by side — one planning, one executing, one analyzing results, one adjusting the plan based on what it sees — coordinating with each other in a continuous loop. These aren't roles we're loosely calling 'Minds.' They're literal Minds models, each doing a distinct job, talking to each other. This is the clearest place you'll see what your platform makes possible when we push it toward real multi-agent coordination.</a:t>
             </a:r>
           </a:p>
         </p:txBody>
@@ -1000,7 +1000,7 @@
           <a:lstStyle/>
           <a:p>
             <a:r>
-              <a:t>One piece of that loop deserves special mention: the analysis Mind. Marketing attribution is hard to get right, and we want it to be genuinely rigorous, not just a dashboard. So we're currently exploring a collaboration with Sapien, with the goal of combining forces to deliver the most professional, rigorous marketing analysis in the space. It's early — an active conversation, not a done deal — but it's a direction we're excited about.</a:t>
+              <a:t>One open thread, for full transparency: we're in early conversations with Sapien about the analyze step in that stage-three loop — whether their approach complements what Minds already gives us. To be clear, this is exploration, not a commitment. We want to be upfront about what's decided and what's still being evaluated, because that honesty is part of how we want to build this relationship with you.</a:t>
             </a:r>
           </a:p>
         </p:txBody>
@@ -1070,7 +1070,7 @@
           <a:lstStyle/>
           <a:p>
             <a:r>
-              <a:t>So to recap: we've already lived through the first two stages ourselves — content assistance, then full single-session execution, which is running today. The next milestone we're chasing is agent mode: persistent, per-brand workspaces where multiple Minds plan, execute, analyze, and adjust in a continuous loop. That's how we turn complex marketing needs into structured, actionable workflows — and that's what drives scalable user growth and real brand impact. We've built the first two stages. Now we're building the third. Thank you.</a:t>
+              <a:t>So: two stages shipped and running, one stage actively in motion, built on Minds from day one — not as an integration bolted on after the fact, but as the foundation. We're showing you this because we think it's a good answer to the question every platform has to answer eventually: what gets built on top of us? We'd like to keep building that answer together — with your platform, and with your community. Thanks for the time.</a:t>
             </a:r>
           </a:p>
         </p:txBody>
@@ -4136,7 +4136,7 @@
         </p:nvSpPr>
         <p:spPr>
           <a:xfrm>
-            <a:off x="822960" y="1965960"/>
+            <a:off x="822960" y="1691640"/>
             <a:ext cx="10058400" cy="457200"/>
           </a:xfrm>
           <a:prstGeom prst="rect">
@@ -4175,8 +4175,8 @@
         </p:nvSpPr>
         <p:spPr>
           <a:xfrm>
-            <a:off x="777240" y="2377440"/>
-            <a:ext cx="10515600" cy="1463040"/>
+            <a:off x="777240" y="2103120"/>
+            <a:ext cx="10515600" cy="1737360"/>
           </a:xfrm>
           <a:prstGeom prst="rect">
             <a:avLst/>
@@ -4201,7 +4201,7 @@
                 </a:solidFill>
                 <a:latin typeface="Avenir Next"/>
               </a:rPr>
-              <a:t>From Assistant</a:t>
+              <a:t>Built on Minds,</a:t>
             </a:r>
           </a:p>
           <a:p>
@@ -4217,7 +4217,7 @@
                 </a:solidFill>
                 <a:latin typeface="Avenir Next"/>
               </a:rPr>
-              <a:t>to Autonomous</a:t>
+              <a:t>From Day One</a:t>
             </a:r>
           </a:p>
         </p:txBody>
@@ -4230,7 +4230,7 @@
         </p:nvSpPr>
         <p:spPr>
           <a:xfrm>
-            <a:off x="822960" y="3977639"/>
+            <a:off x="822960" y="3931920"/>
             <a:ext cx="9601200" cy="548640"/>
           </a:xfrm>
           <a:prstGeom prst="rect">
@@ -4256,7 +4256,7 @@
                 </a:solidFill>
                 <a:latin typeface="Avenir Next"/>
               </a:rPr>
-              <a:t>How we're teaching AI to run the entire brand campaign lifecycle</a:t>
+              <a:t>Powered by Minds, built with Harness.</a:t>
             </a:r>
           </a:p>
         </p:txBody>
@@ -4269,8 +4269,8 @@
         </p:nvSpPr>
         <p:spPr>
           <a:xfrm>
-            <a:off x="822960" y="4800600"/>
-            <a:ext cx="9875520" cy="1463040"/>
+            <a:off x="822960" y="4663440"/>
+            <a:ext cx="9875520" cy="1645920"/>
           </a:xfrm>
           <a:prstGeom prst="rect">
             <a:avLst/>
@@ -4317,7 +4317,7 @@
                 </a:solidFill>
                 <a:latin typeface="Avenir Next"/>
               </a:rPr>
-              <a:t>—  Not a better tool — AI that figures out the strategy</a:t>
+              <a:t>—  Powered by Minds, built with Harness</a:t>
             </a:r>
           </a:p>
           <a:p>
@@ -4336,7 +4336,7 @@
                 </a:solidFill>
                 <a:latin typeface="Avenir Next"/>
               </a:rPr>
-              <a:t>—  Today: where we are, and where we're going next</a:t>
+              <a:t>—  A partnership story, not just a product demo</a:t>
             </a:r>
           </a:p>
         </p:txBody>
@@ -4537,7 +4537,7 @@
         <p:spPr>
           <a:xfrm>
             <a:off x="502920" y="960120"/>
-            <a:ext cx="10515600" cy="822960"/>
+            <a:ext cx="10515600" cy="1188720"/>
           </a:xfrm>
           <a:prstGeom prst="rect">
             <a:avLst/>
@@ -4552,7 +4552,7 @@
           <a:p>
             <a:pPr algn="l">
               <a:lnSpc>
-                <a:spcPct val="115000"/>
+                <a:spcPct val="110000"/>
               </a:lnSpc>
             </a:pPr>
             <a:r>
@@ -4562,7 +4562,23 @@
                 </a:solidFill>
                 <a:latin typeface="Avenir Next"/>
               </a:rPr>
-              <a:t>Brand marketing today is fragmented</a:t>
+              <a:t>Marketing today is stitched</a:t>
+            </a:r>
+          </a:p>
+          <a:p>
+            <a:pPr algn="l">
+              <a:lnSpc>
+                <a:spcPct val="110000"/>
+              </a:lnSpc>
+            </a:pPr>
+            <a:r>
+              <a:rPr sz="3600" b="1" i="0">
+                <a:solidFill>
+                  <a:srgbClr val="F2F4F8"/>
+                </a:solidFill>
+                <a:latin typeface="Avenir Next"/>
+              </a:rPr>
+              <a:t>together by hand</a:t>
             </a:r>
           </a:p>
         </p:txBody>
@@ -4575,7 +4591,7 @@
         </p:nvSpPr>
         <p:spPr>
           <a:xfrm>
-            <a:off x="502920" y="2194560"/>
+            <a:off x="502920" y="2606040"/>
             <a:ext cx="10515600" cy="2926080"/>
           </a:xfrm>
           <a:prstGeom prst="rect">
@@ -4594,17 +4610,17 @@
                 <a:spcPct val="120000"/>
               </a:lnSpc>
               <a:spcAft>
-                <a:spcPts val="2000"/>
+                <a:spcPts val="1800"/>
               </a:spcAft>
             </a:pPr>
             <a:r>
-              <a:rPr sz="2000">
+              <a:rPr sz="1900">
                 <a:solidFill>
                   <a:srgbClr val="F2F4F8"/>
                 </a:solidFill>
                 <a:latin typeface="Avenir Next"/>
               </a:rPr>
-              <a:t>—  Campaign marketing is fragmented across tools</a:t>
+              <a:t>—  One tool for campaign design, another for deployment, a spreadsheet for the rest</a:t>
             </a:r>
           </a:p>
           <a:p>
@@ -4613,17 +4629,17 @@
                 <a:spcPct val="120000"/>
               </a:lnSpc>
               <a:spcAft>
-                <a:spcPts val="2000"/>
+                <a:spcPts val="1800"/>
               </a:spcAft>
             </a:pPr>
             <a:r>
-              <a:rPr sz="2000">
+              <a:rPr sz="1900">
                 <a:solidFill>
                   <a:srgbClr val="F2F4F8"/>
                 </a:solidFill>
                 <a:latin typeface="Avenir Next"/>
               </a:rPr>
-              <a:t>—  Strategy is manual, slow, and inconsistent</a:t>
+              <a:t>—  Campaign design, deployment, resource orchestration — all disconnected</a:t>
             </a:r>
           </a:p>
           <a:p>
@@ -4632,17 +4648,17 @@
                 <a:spcPct val="120000"/>
               </a:lnSpc>
               <a:spcAft>
-                <a:spcPts val="2000"/>
+                <a:spcPts val="1800"/>
               </a:spcAft>
             </a:pPr>
             <a:r>
-              <a:rPr sz="2000">
+              <a:rPr sz="1900">
                 <a:solidFill>
                   <a:srgbClr val="F2F4F8"/>
                 </a:solidFill>
                 <a:latin typeface="Avenir Next"/>
               </a:rPr>
-              <a:t>—  Execution and analysis live in separate silos</a:t>
+              <a:t>—  It doesn't scale, and it doesn't get smarter over time</a:t>
             </a:r>
           </a:p>
           <a:p>
@@ -4651,17 +4667,17 @@
                 <a:spcPct val="120000"/>
               </a:lnSpc>
               <a:spcAft>
-                <a:spcPts val="2000"/>
+                <a:spcPts val="1800"/>
               </a:spcAft>
             </a:pPr>
             <a:r>
-              <a:rPr sz="2000">
+              <a:rPr sz="1900">
                 <a:solidFill>
                   <a:srgbClr val="F2F4F8"/>
                 </a:solidFill>
                 <a:latin typeface="Avenir Next"/>
               </a:rPr>
-              <a:t>—  No real feedback loop back into the next campaign</a:t>
+              <a:t>—  The fix isn't another point tool — it's a system that reasons across the whole lifecycle</a:t>
             </a:r>
           </a:p>
         </p:txBody>
@@ -4700,7 +4716,7 @@
                 </a:solidFill>
                 <a:latin typeface="Avenir Next"/>
               </a:rPr>
-              <a:t>LaunchMinds  ·  From Assistant to Autonomous  ·  2026</a:t>
+              <a:t>LaunchMinds  ·  Built on Minds  ·  2026</a:t>
             </a:r>
           </a:p>
         </p:txBody>
@@ -4861,7 +4877,7 @@
         </p:nvSpPr>
         <p:spPr>
           <a:xfrm>
-            <a:off x="502920" y="960120"/>
+            <a:off x="502920" y="914400"/>
             <a:ext cx="10515600" cy="640080"/>
           </a:xfrm>
           <a:prstGeom prst="rect">
@@ -4881,13 +4897,13 @@
               </a:lnSpc>
             </a:pPr>
             <a:r>
-              <a:rPr sz="3600" b="1" i="0">
+              <a:rPr sz="3400" b="1" i="0">
                 <a:solidFill>
                   <a:srgbClr val="F2F4F8"/>
                 </a:solidFill>
                 <a:latin typeface="Avenir Next"/>
               </a:rPr>
-              <a:t>What LaunchMinds is, today</a:t>
+              <a:t>LaunchMinds = Harness + Minds</a:t>
             </a:r>
           </a:p>
         </p:txBody>
@@ -4900,12 +4916,12 @@
         </p:nvSpPr>
         <p:spPr>
           <a:xfrm>
-            <a:off x="502920" y="1874519"/>
-            <a:ext cx="11155680" cy="2331720"/>
+            <a:off x="502920" y="1691640"/>
+            <a:ext cx="4937760" cy="914400"/>
           </a:xfrm>
           <a:prstGeom prst="roundRect">
             <a:avLst>
-              <a:gd name="adj" fmla="val 6000"/>
+              <a:gd name="adj" fmla="val 8000"/>
             </a:avLst>
           </a:prstGeom>
           <a:solidFill>
@@ -4940,14 +4956,345 @@
       </p:sp>
       <p:sp>
         <p:nvSpPr>
-          <p:cNvPr id="7" name="Rectangle 6"/>
+          <p:cNvPr id="7" name="TextBox 6"/>
+          <p:cNvSpPr txBox="1"/>
+          <p:nvPr/>
+        </p:nvSpPr>
+        <p:spPr>
+          <a:xfrm>
+            <a:off x="822960" y="1837944"/>
+            <a:ext cx="4297680" cy="320040"/>
+          </a:xfrm>
+          <a:prstGeom prst="rect">
+            <a:avLst/>
+          </a:prstGeom>
+          <a:noFill/>
+        </p:spPr>
+        <p:txBody>
+          <a:bodyPr wrap="square" anchor="t">
+            <a:spAutoFit/>
+          </a:bodyPr>
+          <a:lstStyle/>
+          <a:p>
+            <a:pPr algn="l">
+              <a:lnSpc>
+                <a:spcPct val="115000"/>
+              </a:lnSpc>
+            </a:pPr>
+            <a:r>
+              <a:rPr sz="1500" b="1" i="0">
+                <a:solidFill>
+                  <a:srgbClr val="5EE6C0"/>
+                </a:solidFill>
+                <a:latin typeface="Avenir Next"/>
+              </a:rPr>
+              <a:t>HARNESS</a:t>
+            </a:r>
+          </a:p>
+        </p:txBody>
+      </p:sp>
+      <p:sp>
+        <p:nvSpPr>
+          <p:cNvPr id="8" name="TextBox 7"/>
+          <p:cNvSpPr txBox="1"/>
+          <p:nvPr/>
+        </p:nvSpPr>
+        <p:spPr>
+          <a:xfrm>
+            <a:off x="822960" y="2167128"/>
+            <a:ext cx="4297680" cy="365760"/>
+          </a:xfrm>
+          <a:prstGeom prst="rect">
+            <a:avLst/>
+          </a:prstGeom>
+          <a:noFill/>
+        </p:spPr>
+        <p:txBody>
+          <a:bodyPr wrap="square" anchor="t">
+            <a:spAutoFit/>
+          </a:bodyPr>
+          <a:lstStyle/>
+          <a:p>
+            <a:pPr algn="l">
+              <a:lnSpc>
+                <a:spcPct val="115000"/>
+              </a:lnSpc>
+            </a:pPr>
+            <a:r>
+              <a:rPr sz="1350" b="0" i="0">
+                <a:solidFill>
+                  <a:srgbClr val="A6AFC2"/>
+                </a:solidFill>
+                <a:latin typeface="Avenir Next"/>
+              </a:rPr>
+              <a:t>Context layer — proprietary enterprise memory</a:t>
+            </a:r>
+          </a:p>
+        </p:txBody>
+      </p:sp>
+      <p:sp>
+        <p:nvSpPr>
+          <p:cNvPr id="9" name="TextBox 8"/>
+          <p:cNvSpPr txBox="1"/>
+          <p:nvPr/>
+        </p:nvSpPr>
+        <p:spPr>
+          <a:xfrm>
+            <a:off x="5623560" y="1947672"/>
+            <a:ext cx="457200" cy="457200"/>
+          </a:xfrm>
+          <a:prstGeom prst="rect">
+            <a:avLst/>
+          </a:prstGeom>
+          <a:noFill/>
+        </p:spPr>
+        <p:txBody>
+          <a:bodyPr wrap="square" anchor="t">
+            <a:spAutoFit/>
+          </a:bodyPr>
+          <a:lstStyle/>
+          <a:p>
+            <a:pPr algn="ctr">
+              <a:lnSpc>
+                <a:spcPct val="115000"/>
+              </a:lnSpc>
+            </a:pPr>
+            <a:r>
+              <a:rPr sz="3000" b="0" i="0">
+                <a:solidFill>
+                  <a:srgbClr val="6B748C"/>
+                </a:solidFill>
+                <a:latin typeface="Avenir Next"/>
+              </a:rPr>
+              <a:t>+</a:t>
+            </a:r>
+          </a:p>
+        </p:txBody>
+      </p:sp>
+      <p:sp>
+        <p:nvSpPr>
+          <p:cNvPr id="10" name="Rounded Rectangle 9"/>
           <p:cNvSpPr/>
           <p:nvPr/>
         </p:nvSpPr>
         <p:spPr>
           <a:xfrm>
-            <a:off x="502920" y="1874519"/>
-            <a:ext cx="82296" cy="2331720"/>
+            <a:off x="6263640" y="1691640"/>
+            <a:ext cx="4937760" cy="914400"/>
+          </a:xfrm>
+          <a:prstGeom prst="roundRect">
+            <a:avLst>
+              <a:gd name="adj" fmla="val 8000"/>
+            </a:avLst>
+          </a:prstGeom>
+          <a:solidFill>
+            <a:srgbClr val="182138"/>
+          </a:solidFill>
+          <a:ln>
+            <a:noFill/>
+          </a:ln>
+          <a:effectLst/>
+        </p:spPr>
+        <p:style>
+          <a:lnRef idx="1">
+            <a:schemeClr val="accent1"/>
+          </a:lnRef>
+          <a:fillRef idx="3">
+            <a:schemeClr val="accent1"/>
+          </a:fillRef>
+          <a:effectRef idx="2">
+            <a:schemeClr val="accent1"/>
+          </a:effectRef>
+          <a:fontRef idx="minor">
+            <a:schemeClr val="lt1"/>
+          </a:fontRef>
+        </p:style>
+        <p:txBody>
+          <a:bodyPr rtlCol="0" anchor="ctr"/>
+          <a:lstStyle/>
+          <a:p>
+            <a:pPr algn="ctr"/>
+          </a:p>
+        </p:txBody>
+      </p:sp>
+      <p:sp>
+        <p:nvSpPr>
+          <p:cNvPr id="11" name="Rectangle 10"/>
+          <p:cNvSpPr/>
+          <p:nvPr/>
+        </p:nvSpPr>
+        <p:spPr>
+          <a:xfrm>
+            <a:off x="6263640" y="1691640"/>
+            <a:ext cx="73152" cy="914400"/>
+          </a:xfrm>
+          <a:prstGeom prst="rect">
+            <a:avLst/>
+          </a:prstGeom>
+          <a:solidFill>
+            <a:srgbClr val="7C9CFF"/>
+          </a:solidFill>
+          <a:ln>
+            <a:noFill/>
+          </a:ln>
+          <a:effectLst/>
+        </p:spPr>
+        <p:style>
+          <a:lnRef idx="1">
+            <a:schemeClr val="accent1"/>
+          </a:lnRef>
+          <a:fillRef idx="3">
+            <a:schemeClr val="accent1"/>
+          </a:fillRef>
+          <a:effectRef idx="2">
+            <a:schemeClr val="accent1"/>
+          </a:effectRef>
+          <a:fontRef idx="minor">
+            <a:schemeClr val="lt1"/>
+          </a:fontRef>
+        </p:style>
+        <p:txBody>
+          <a:bodyPr rtlCol="0" anchor="ctr"/>
+          <a:lstStyle/>
+          <a:p>
+            <a:pPr algn="ctr"/>
+          </a:p>
+        </p:txBody>
+      </p:sp>
+      <p:sp>
+        <p:nvSpPr>
+          <p:cNvPr id="12" name="TextBox 11"/>
+          <p:cNvSpPr txBox="1"/>
+          <p:nvPr/>
+        </p:nvSpPr>
+        <p:spPr>
+          <a:xfrm>
+            <a:off x="6583680" y="1837944"/>
+            <a:ext cx="4297680" cy="320040"/>
+          </a:xfrm>
+          <a:prstGeom prst="rect">
+            <a:avLst/>
+          </a:prstGeom>
+          <a:noFill/>
+        </p:spPr>
+        <p:txBody>
+          <a:bodyPr wrap="square" anchor="t">
+            <a:spAutoFit/>
+          </a:bodyPr>
+          <a:lstStyle/>
+          <a:p>
+            <a:pPr algn="l">
+              <a:lnSpc>
+                <a:spcPct val="115000"/>
+              </a:lnSpc>
+            </a:pPr>
+            <a:r>
+              <a:rPr sz="1500" b="1" i="0">
+                <a:solidFill>
+                  <a:srgbClr val="7C9CFF"/>
+                </a:solidFill>
+                <a:latin typeface="Avenir Next"/>
+              </a:rPr>
+              <a:t>MINDS</a:t>
+            </a:r>
+          </a:p>
+        </p:txBody>
+      </p:sp>
+      <p:sp>
+        <p:nvSpPr>
+          <p:cNvPr id="13" name="TextBox 12"/>
+          <p:cNvSpPr txBox="1"/>
+          <p:nvPr/>
+        </p:nvSpPr>
+        <p:spPr>
+          <a:xfrm>
+            <a:off x="6583680" y="2167128"/>
+            <a:ext cx="4297680" cy="365760"/>
+          </a:xfrm>
+          <a:prstGeom prst="rect">
+            <a:avLst/>
+          </a:prstGeom>
+          <a:noFill/>
+        </p:spPr>
+        <p:txBody>
+          <a:bodyPr wrap="square" anchor="t">
+            <a:spAutoFit/>
+          </a:bodyPr>
+          <a:lstStyle/>
+          <a:p>
+            <a:pPr algn="l">
+              <a:lnSpc>
+                <a:spcPct val="115000"/>
+              </a:lnSpc>
+            </a:pPr>
+            <a:r>
+              <a:rPr sz="1350" b="0" i="0">
+                <a:solidFill>
+                  <a:srgbClr val="A6AFC2"/>
+                </a:solidFill>
+                <a:latin typeface="Avenir Next"/>
+              </a:rPr>
+              <a:t>Model layer — the reasoning engine underneath</a:t>
+            </a:r>
+          </a:p>
+        </p:txBody>
+      </p:sp>
+      <p:sp>
+        <p:nvSpPr>
+          <p:cNvPr id="14" name="Rounded Rectangle 13"/>
+          <p:cNvSpPr/>
+          <p:nvPr/>
+        </p:nvSpPr>
+        <p:spPr>
+          <a:xfrm>
+            <a:off x="502920" y="2926080"/>
+            <a:ext cx="11155680" cy="1874519"/>
+          </a:xfrm>
+          <a:prstGeom prst="roundRect">
+            <a:avLst>
+              <a:gd name="adj" fmla="val 6000"/>
+            </a:avLst>
+          </a:prstGeom>
+          <a:solidFill>
+            <a:srgbClr val="141B2E"/>
+          </a:solidFill>
+          <a:ln>
+            <a:noFill/>
+          </a:ln>
+          <a:effectLst/>
+        </p:spPr>
+        <p:style>
+          <a:lnRef idx="1">
+            <a:schemeClr val="accent1"/>
+          </a:lnRef>
+          <a:fillRef idx="3">
+            <a:schemeClr val="accent1"/>
+          </a:fillRef>
+          <a:effectRef idx="2">
+            <a:schemeClr val="accent1"/>
+          </a:effectRef>
+          <a:fontRef idx="minor">
+            <a:schemeClr val="lt1"/>
+          </a:fontRef>
+        </p:style>
+        <p:txBody>
+          <a:bodyPr rtlCol="0" anchor="ctr"/>
+          <a:lstStyle/>
+          <a:p>
+            <a:pPr algn="ctr"/>
+          </a:p>
+        </p:txBody>
+      </p:sp>
+      <p:sp>
+        <p:nvSpPr>
+          <p:cNvPr id="15" name="Rectangle 14"/>
+          <p:cNvSpPr/>
+          <p:nvPr/>
+        </p:nvSpPr>
+        <p:spPr>
+          <a:xfrm>
+            <a:off x="502920" y="2926080"/>
+            <a:ext cx="82296" cy="1874519"/>
           </a:xfrm>
           <a:prstGeom prst="rect">
             <a:avLst/>
@@ -4984,14 +5331,14 @@
       </p:sp>
       <p:sp>
         <p:nvSpPr>
-          <p:cNvPr id="8" name="TextBox 7"/>
+          <p:cNvPr id="16" name="TextBox 15"/>
           <p:cNvSpPr txBox="1"/>
           <p:nvPr/>
         </p:nvSpPr>
         <p:spPr>
           <a:xfrm>
-            <a:off x="914400" y="2103120"/>
-            <a:ext cx="10332720" cy="1920240"/>
+            <a:off x="914400" y="3108960"/>
+            <a:ext cx="10332720" cy="1554480"/>
           </a:xfrm>
           <a:prstGeom prst="rect">
             <a:avLst/>
@@ -5006,11 +5353,11 @@
           <a:p>
             <a:pPr algn="l">
               <a:lnSpc>
-                <a:spcPct val="130000"/>
-              </a:lnSpc>
-            </a:pPr>
-            <a:r>
-              <a:rPr sz="2200" b="0" i="1">
+                <a:spcPct val="128000"/>
+              </a:lnSpc>
+            </a:pPr>
+            <a:r>
+              <a:rPr sz="1850" b="0" i="1">
                 <a:solidFill>
                   <a:srgbClr val="F2F4F8"/>
                 </a:solidFill>
@@ -5023,94 +5370,14 @@
       </p:sp>
       <p:sp>
         <p:nvSpPr>
-          <p:cNvPr id="9" name="TextBox 8"/>
+          <p:cNvPr id="17" name="TextBox 16"/>
           <p:cNvSpPr txBox="1"/>
           <p:nvPr/>
         </p:nvSpPr>
         <p:spPr>
           <a:xfrm>
-            <a:off x="502920" y="4526280"/>
-            <a:ext cx="10515600" cy="1463040"/>
-          </a:xfrm>
-          <a:prstGeom prst="rect">
-            <a:avLst/>
-          </a:prstGeom>
-          <a:noFill/>
-        </p:spPr>
-        <p:txBody>
-          <a:bodyPr wrap="square">
-            <a:spAutoFit/>
-          </a:bodyPr>
-          <a:lstStyle/>
-          <a:p>
-            <a:pPr>
-              <a:lnSpc>
-                <a:spcPct val="120000"/>
-              </a:lnSpc>
-              <a:spcAft>
-                <a:spcPts val="1000"/>
-              </a:spcAft>
-            </a:pPr>
-            <a:r>
-              <a:rPr sz="1650">
-                <a:solidFill>
-                  <a:srgbClr val="A6AFC2"/>
-                </a:solidFill>
-                <a:latin typeface="Avenir Next"/>
-              </a:rPr>
-              <a:t>—  Transforms complex marketing needs into structured, actionable workflows</a:t>
-            </a:r>
-          </a:p>
-          <a:p>
-            <a:pPr>
-              <a:lnSpc>
-                <a:spcPct val="120000"/>
-              </a:lnSpc>
-              <a:spcAft>
-                <a:spcPts val="1000"/>
-              </a:spcAft>
-            </a:pPr>
-            <a:r>
-              <a:rPr sz="1650">
-                <a:solidFill>
-                  <a:srgbClr val="A6AFC2"/>
-                </a:solidFill>
-                <a:latin typeface="Avenir Next"/>
-              </a:rPr>
-              <a:t>—  Drives scalable user growth and brand impact</a:t>
-            </a:r>
-          </a:p>
-          <a:p>
-            <a:pPr>
-              <a:lnSpc>
-                <a:spcPct val="120000"/>
-              </a:lnSpc>
-              <a:spcAft>
-                <a:spcPts val="1000"/>
-              </a:spcAft>
-            </a:pPr>
-            <a:r>
-              <a:rPr sz="1650">
-                <a:solidFill>
-                  <a:srgbClr val="A6AFC2"/>
-                </a:solidFill>
-                <a:latin typeface="Avenir Next"/>
-              </a:rPr>
-              <a:t>—  Harness = the mechanism that builds a persistent, proprietary brand context</a:t>
-            </a:r>
-          </a:p>
-        </p:txBody>
-      </p:sp>
-      <p:sp>
-        <p:nvSpPr>
-          <p:cNvPr id="10" name="TextBox 9"/>
-          <p:cNvSpPr txBox="1"/>
-          <p:nvPr/>
-        </p:nvSpPr>
-        <p:spPr>
-          <a:xfrm>
-            <a:off x="502920" y="6492240"/>
-            <a:ext cx="8229600" cy="274320"/>
+            <a:off x="502920" y="5074920"/>
+            <a:ext cx="10789920" cy="822960"/>
           </a:xfrm>
           <a:prstGeom prst="rect">
             <a:avLst/>
@@ -5125,6 +5392,61 @@
           <a:p>
             <a:pPr algn="l">
               <a:lnSpc>
+                <a:spcPct val="130000"/>
+              </a:lnSpc>
+            </a:pPr>
+            <a:r>
+              <a:rPr sz="1650" b="0" i="1">
+                <a:solidFill>
+                  <a:srgbClr val="5EE6C0"/>
+                </a:solidFill>
+                <a:latin typeface="Avenir Next"/>
+              </a:rPr>
+              <a:t>Harness without Minds is just a database. Minds without Harness is generic.</a:t>
+            </a:r>
+          </a:p>
+          <a:p>
+            <a:pPr algn="l">
+              <a:lnSpc>
+                <a:spcPct val="130000"/>
+              </a:lnSpc>
+            </a:pPr>
+            <a:r>
+              <a:rPr sz="1650" b="0" i="1">
+                <a:solidFill>
+                  <a:srgbClr val="5EE6C0"/>
+                </a:solidFill>
+                <a:latin typeface="Avenir Next"/>
+              </a:rPr>
+              <a:t>Together, that's Minds-driven — not just Minds-adjacent.</a:t>
+            </a:r>
+          </a:p>
+        </p:txBody>
+      </p:sp>
+      <p:sp>
+        <p:nvSpPr>
+          <p:cNvPr id="18" name="TextBox 17"/>
+          <p:cNvSpPr txBox="1"/>
+          <p:nvPr/>
+        </p:nvSpPr>
+        <p:spPr>
+          <a:xfrm>
+            <a:off x="502920" y="6492240"/>
+            <a:ext cx="8229600" cy="274320"/>
+          </a:xfrm>
+          <a:prstGeom prst="rect">
+            <a:avLst/>
+          </a:prstGeom>
+          <a:noFill/>
+        </p:spPr>
+        <p:txBody>
+          <a:bodyPr wrap="square" anchor="t">
+            <a:spAutoFit/>
+          </a:bodyPr>
+          <a:lstStyle/>
+          <a:p>
+            <a:pPr algn="l">
+              <a:lnSpc>
                 <a:spcPct val="115000"/>
               </a:lnSpc>
             </a:pPr>
@@ -5135,7 +5457,7 @@
                 </a:solidFill>
                 <a:latin typeface="Avenir Next"/>
               </a:rPr>
-              <a:t>LaunchMinds  ·  From Assistant to Autonomous  ·  2026</a:t>
+              <a:t>LaunchMinds  ·  Built on Minds  ·  2026</a:t>
             </a:r>
           </a:p>
         </p:txBody>
@@ -5322,7 +5644,7 @@
                 </a:solidFill>
                 <a:latin typeface="Avenir Next"/>
               </a:rPr>
-              <a:t>A familiar pattern</a:t>
+              <a:t>How agents evolve</a:t>
             </a:r>
           </a:p>
         </p:txBody>
@@ -5361,7 +5683,7 @@
                 </a:solidFill>
                 <a:latin typeface="Avenir Next"/>
               </a:rPr>
-              <a:t>AI-assisted coding evolved through three recognizable stages.</a:t>
+              <a:t>The same arc coding tools went through.</a:t>
             </a:r>
           </a:p>
           <a:p>
@@ -5377,7 +5699,7 @@
                 </a:solidFill>
                 <a:latin typeface="Avenir Next"/>
               </a:rPr>
-              <a:t>LaunchMinds is climbing the exact same ladder.</a:t>
+              <a:t>We're climbing it stage by stage — natively on Minds.</a:t>
             </a:r>
           </a:p>
         </p:txBody>
@@ -5914,7 +6236,7 @@
                 </a:solidFill>
                 <a:latin typeface="Avenir Next"/>
               </a:rPr>
-              <a:t>We're not guessing at the roadmap — we're following a proven curve.</a:t>
+              <a:t>Each stage is a Minds workflow — not a script with a model bolted on.</a:t>
             </a:r>
           </a:p>
         </p:txBody>
@@ -5953,7 +6275,7 @@
                 </a:solidFill>
                 <a:latin typeface="Avenir Next"/>
               </a:rPr>
-              <a:t>LaunchMinds  ·  From Assistant to Autonomous  ·  2026</a:t>
+              <a:t>LaunchMinds  ·  Built on Minds  ·  2026</a:t>
             </a:r>
           </a:p>
         </p:txBody>
@@ -6321,7 +6643,7 @@
                 </a:solidFill>
                 <a:latin typeface="Avenir Next"/>
               </a:rPr>
-              <a:t>Inline autocomplete</a:t>
+              <a:t>Inline suggestions, not action</a:t>
             </a:r>
           </a:p>
         </p:txBody>
@@ -6363,7 +6685,7 @@
                 </a:solidFill>
                 <a:latin typeface="Avenir Next"/>
               </a:rPr>
-              <a:t>—  Early Copilot-style tools</a:t>
+              <a:t>—  Suggestions only — human reviews every one</a:t>
             </a:r>
           </a:p>
           <a:p>
@@ -6382,26 +6704,7 @@
                 </a:solidFill>
                 <a:latin typeface="Avenir Next"/>
               </a:rPr>
-              <a:t>—  Human drives, AI suggests fragments</a:t>
-            </a:r>
-          </a:p>
-          <a:p>
-            <a:pPr>
-              <a:lnSpc>
-                <a:spcPct val="120000"/>
-              </a:lnSpc>
-              <a:spcAft>
-                <a:spcPts val="1200"/>
-              </a:spcAft>
-            </a:pPr>
-            <a:r>
-              <a:rPr sz="1450">
-                <a:solidFill>
-                  <a:srgbClr val="A6AFC2"/>
-                </a:solidFill>
-                <a:latin typeface="Avenir Next"/>
-              </a:rPr>
-              <a:t>—  Bounded to the next few lines</a:t>
+              <a:t>—  Human stays in control of the outcome</a:t>
             </a:r>
           </a:p>
         </p:txBody>
@@ -6530,7 +6833,7 @@
                 </a:solidFill>
                 <a:latin typeface="Avenir Next"/>
               </a:rPr>
-              <a:t>IN LAUNCHMINDS</a:t>
+              <a:t>ON MINDS, IN LAUNCHMINDS</a:t>
             </a:r>
           </a:p>
         </p:txBody>
@@ -6569,7 +6872,7 @@
                 </a:solidFill>
                 <a:latin typeface="Avenir Next"/>
               </a:rPr>
-              <a:t>AI-assisted campaign copy</a:t>
+              <a:t>Minds-assisted campaign drafting</a:t>
             </a:r>
           </a:p>
         </p:txBody>
@@ -6611,7 +6914,7 @@
                 </a:solidFill>
                 <a:latin typeface="Avenir Next"/>
               </a:rPr>
-              <a:t>—  AI helped write campaign copy &amp; task descriptions</a:t>
+              <a:t>—  Minds proposes structure, drafts copy</a:t>
             </a:r>
           </a:p>
           <a:p>
@@ -6630,7 +6933,7 @@
                 </a:solidFill>
                 <a:latin typeface="Avenir Next"/>
               </a:rPr>
-              <a:t>—  Human still designed and assembled the whole campaign</a:t>
+              <a:t>—  Pulls in context Harness has already stored</a:t>
             </a:r>
           </a:p>
           <a:p>
@@ -6649,7 +6952,7 @@
                 </a:solidFill>
                 <a:latin typeface="Avenir Next"/>
               </a:rPr>
-              <a:t>—  Useful, but narrow</a:t>
+              <a:t>—  Human in the loop at every step</a:t>
             </a:r>
           </a:p>
         </p:txBody>
@@ -6688,7 +6991,7 @@
                 </a:solidFill>
                 <a:latin typeface="Avenir Next"/>
               </a:rPr>
-              <a:t>This was our starting point — already behind us.</a:t>
+              <a:t>Already saving our team real hours today.</a:t>
             </a:r>
           </a:p>
         </p:txBody>
@@ -6727,7 +7030,7 @@
                 </a:solidFill>
                 <a:latin typeface="Avenir Next"/>
               </a:rPr>
-              <a:t>LaunchMinds  ·  From Assistant to Autonomous  ·  2026</a:t>
+              <a:t>LaunchMinds  ·  Built on Minds  ·  2026</a:t>
             </a:r>
           </a:p>
         </p:txBody>
@@ -7095,7 +7398,7 @@
                 </a:solidFill>
                 <a:latin typeface="Avenir Next"/>
               </a:rPr>
-              <a:t>One session, full execution</a:t>
+              <a:t>Full task, one sitting, human watching</a:t>
             </a:r>
           </a:p>
         </p:txBody>
@@ -7137,7 +7440,7 @@
                 </a:solidFill>
                 <a:latin typeface="Avenir Next"/>
               </a:rPr>
-              <a:t>—  A full brief goes in, one LLM session executes it end-to-end</a:t>
+              <a:t>—  One session completes an entire task</a:t>
             </a:r>
           </a:p>
           <a:p>
@@ -7156,7 +7459,7 @@
                 </a:solidFill>
                 <a:latin typeface="Avenir Next"/>
               </a:rPr>
-              <a:t>—  Bounded to one continuous session, one thread</a:t>
+              <a:t>—  A human observes, doesn't drive step by step</a:t>
             </a:r>
           </a:p>
         </p:txBody>
@@ -7285,7 +7588,7 @@
                 </a:solidFill>
                 <a:latin typeface="Avenir Next"/>
               </a:rPr>
-              <a:t>IN LAUNCHMINDS</a:t>
+              <a:t>ON MINDS, IN LAUNCHMINDS</a:t>
             </a:r>
           </a:p>
         </p:txBody>
@@ -7324,7 +7627,7 @@
                 </a:solidFill>
                 <a:latin typeface="Avenir Next"/>
               </a:rPr>
-              <a:t>Registration → Plan → Deploy, in one pass</a:t>
+              <a:t>One session, one Mind, full pipeline</a:t>
             </a:r>
           </a:p>
         </p:txBody>
@@ -7366,7 +7669,7 @@
                 </a:solidFill>
                 <a:latin typeface="Avenir Next"/>
               </a:rPr>
-              <a:t>—  One session handles registration, strategy planning, AND deployment</a:t>
+              <a:t>—  Registration + planning + deployment — no handoffs between tools</a:t>
             </a:r>
           </a:p>
           <a:p>
@@ -7385,7 +7688,7 @@
                 </a:solidFill>
                 <a:latin typeface="Avenir Next"/>
               </a:rPr>
-              <a:t>—  Powered by our internal skill system — encodes the full campaign schema</a:t>
+              <a:t>—  Runs on our internal skill system: structured capabilities we hand to Minds so it can act, not just suggest</a:t>
             </a:r>
           </a:p>
           <a:p>
@@ -7404,7 +7707,7 @@
                 </a:solidFill>
                 <a:latin typeface="Avenir Next"/>
               </a:rPr>
-              <a:t>—  Brief in, live campaign out — shipped and working today</a:t>
+              <a:t>—  Minds doing real autonomous work within a session — live in production today</a:t>
             </a:r>
           </a:p>
         </p:txBody>
@@ -7443,7 +7746,7 @@
                 </a:solidFill>
                 <a:latin typeface="Avenir Next"/>
               </a:rPr>
-              <a:t>This is real. This is where LaunchMinds stands right now.</a:t>
+              <a:t>The first stage where Minds truly acts, not just assists.</a:t>
             </a:r>
           </a:p>
         </p:txBody>
@@ -7482,7 +7785,7 @@
                 </a:solidFill>
                 <a:latin typeface="Avenir Next"/>
               </a:rPr>
-              <a:t>LaunchMinds  ·  From Assistant to Autonomous  ·  2026</a:t>
+              <a:t>LaunchMinds  ·  Built on Minds  ·  2026</a:t>
             </a:r>
           </a:p>
         </p:txBody>
@@ -7850,7 +8153,7 @@
                 </a:solidFill>
                 <a:latin typeface="Avenir Next"/>
               </a:rPr>
-              <a:t>Persistent, multi-agent systems</a:t>
+              <a:t>Long-running, autonomous, self-checking</a:t>
             </a:r>
           </a:p>
         </p:txBody>
@@ -7892,7 +8195,7 @@
                 </a:solidFill>
                 <a:latin typeface="Avenir Next"/>
               </a:rPr>
-              <a:t>—  Not one bounded session — a persistent system</a:t>
+              <a:t>—  Not one session — a persistent, ongoing system</a:t>
             </a:r>
           </a:p>
           <a:p>
@@ -7911,26 +8214,7 @@
                 </a:solidFill>
                 <a:latin typeface="Avenir Next"/>
               </a:rPr>
-              <a:t>—  Multiple agents, each with a role</a:t>
-            </a:r>
-          </a:p>
-          <a:p>
-            <a:pPr>
-              <a:lnSpc>
-                <a:spcPct val="120000"/>
-              </a:lnSpc>
-              <a:spcAft>
-                <a:spcPts val="1200"/>
-              </a:spcAft>
-            </a:pPr>
-            <a:r>
-              <a:rPr sz="1450">
-                <a:solidFill>
-                  <a:srgbClr val="A6AFC2"/>
-                </a:solidFill>
-                <a:latin typeface="Avenir Next"/>
-              </a:rPr>
-              <a:t>—  Coordinate with each other over time</a:t>
+              <a:t>—  Checks and corrects its own work over time</a:t>
             </a:r>
           </a:p>
         </p:txBody>
@@ -8059,7 +8343,7 @@
                 </a:solidFill>
                 <a:latin typeface="Avenir Next"/>
               </a:rPr>
-              <a:t>IN LAUNCHMINDS</a:t>
+              <a:t>ON MINDS, IN LAUNCHMINDS</a:t>
             </a:r>
           </a:p>
         </p:txBody>
@@ -8098,7 +8382,7 @@
                 </a:solidFill>
                 <a:latin typeface="Avenir Next"/>
               </a:rPr>
-              <a:t>A workspace per project, seeded by Harness</a:t>
+              <a:t>A workspace of multiple Minds instances</a:t>
             </a:r>
           </a:p>
         </p:txBody>
@@ -8140,7 +8424,7 @@
                 </a:solidFill>
                 <a:latin typeface="Avenir Next"/>
               </a:rPr>
-              <a:t>—  Persistent workspace for every project / brand</a:t>
+              <a:t>—  Per-project workspace: one Mind plans, one executes, one analyzes, one adjusts</a:t>
             </a:r>
           </a:p>
           <a:p>
@@ -8159,7 +8443,7 @@
                 </a:solidFill>
                 <a:latin typeface="Avenir Next"/>
               </a:rPr>
-              <a:t>—  Multiple “Minds” divide the labor: plan, execute, analyze, adjust</a:t>
+              <a:t>—  Not roles loosely called “Minds” — literal Minds models, coordinating in a loop</a:t>
             </a:r>
           </a:p>
           <a:p>
@@ -8178,7 +8462,7 @@
                 </a:solidFill>
                 <a:latin typeface="Avenir Next"/>
               </a:rPr>
-              <a:t>—  A continuous, self-improving loop — not one-shot</a:t>
+              <a:t>—  Where we push toward real multi-agent coordination on your platform</a:t>
             </a:r>
           </a:p>
         </p:txBody>
@@ -8217,7 +8501,7 @@
                 </a:solidFill>
                 <a:latin typeface="Avenir Next"/>
               </a:rPr>
-              <a:t>The milestone we're now chasing.</a:t>
+              <a:t>The clearest place you'll see what your platform makes possible.</a:t>
             </a:r>
           </a:p>
         </p:txBody>
@@ -8256,7 +8540,7 @@
                 </a:solidFill>
                 <a:latin typeface="Avenir Next"/>
               </a:rPr>
-              <a:t>LaunchMinds  ·  From Assistant to Autonomous  ·  2026</a:t>
+              <a:t>LaunchMinds  ·  Built on Minds  ·  2026</a:t>
             </a:r>
           </a:p>
         </p:txBody>
@@ -8365,7 +8649,7 @@
                 </a:solidFill>
                 <a:latin typeface="Avenir Next"/>
               </a:rPr>
-              <a:t>PARTNERSHIP</a:t>
+              <a:t>EXPLORING</a:t>
             </a:r>
           </a:p>
         </p:txBody>
@@ -8443,7 +8727,7 @@
                 </a:solidFill>
                 <a:latin typeface="Avenir Next"/>
               </a:rPr>
-              <a:t>Raising the bar on analysis</a:t>
+              <a:t>One open thread: Sapien</a:t>
             </a:r>
           </a:p>
         </p:txBody>
@@ -8542,7 +8826,7 @@
                 </a:solidFill>
                 <a:latin typeface="Avenir Next"/>
               </a:rPr>
-              <a:t>—  The “analyze” Mind is only as good as its rigor</a:t>
+              <a:t>—  Early conversations, not finalized</a:t>
             </a:r>
           </a:p>
           <a:p>
@@ -8561,7 +8845,7 @@
                 </a:solidFill>
                 <a:latin typeface="Avenir Next"/>
               </a:rPr>
-              <a:t>—  We're exploring a collaboration with Sapien</a:t>
+              <a:t>—  Potential collaboration on the “analyze” step of the Stage 3 loop</a:t>
             </a:r>
           </a:p>
           <a:p>
@@ -8580,7 +8864,7 @@
                 </a:solidFill>
                 <a:latin typeface="Avenir Next"/>
               </a:rPr>
-              <a:t>—  Goal: combine forces for the most professional, rigorous marketing analysis possible</a:t>
+              <a:t>—  Evaluating whether their approach complements what Minds already gives us</a:t>
             </a:r>
           </a:p>
           <a:p>
@@ -8599,7 +8883,7 @@
                 </a:solidFill>
                 <a:latin typeface="Avenir Next"/>
               </a:rPr>
-              <a:t>—  Active conversation — not yet finalized</a:t>
+              <a:t>—  Full transparency: exploration, not a commitment</a:t>
             </a:r>
           </a:p>
         </p:txBody>
@@ -8638,7 +8922,7 @@
                 </a:solidFill>
                 <a:latin typeface="Avenir Next"/>
               </a:rPr>
-              <a:t>LaunchMinds  ·  From Assistant to Autonomous  ·  2026</a:t>
+              <a:t>LaunchMinds  ·  Built on Minds  ·  2026</a:t>
             </a:r>
           </a:p>
         </p:txBody>
@@ -8747,7 +9031,7 @@
                 </a:solidFill>
                 <a:latin typeface="Avenir Next"/>
               </a:rPr>
-              <a:t>WHERE THIS IS GOING</a:t>
+              <a:t>WHERE THIS GOES</a:t>
             </a:r>
           </a:p>
         </p:txBody>
@@ -8819,13 +9103,13 @@
               </a:lnSpc>
             </a:pPr>
             <a:r>
-              <a:rPr sz="3600" b="1" i="0">
+              <a:rPr sz="3200" b="1" i="0">
                 <a:solidFill>
                   <a:srgbClr val="F2F4F8"/>
                 </a:solidFill>
                 <a:latin typeface="Avenir Next"/>
               </a:rPr>
-              <a:t>Built. Shipping. Building next.</a:t>
+              <a:t>Built on Minds — with Minds' community</a:t>
             </a:r>
           </a:p>
         </p:txBody>
@@ -8838,7 +9122,7 @@
         </p:nvSpPr>
         <p:spPr>
           <a:xfrm>
-            <a:off x="502920" y="1920240"/>
+            <a:off x="502920" y="1828800"/>
             <a:ext cx="3337560" cy="1554480"/>
           </a:xfrm>
           <a:prstGeom prst="roundRect">
@@ -8884,7 +9168,7 @@
         </p:nvSpPr>
         <p:spPr>
           <a:xfrm>
-            <a:off x="502920" y="1920240"/>
+            <a:off x="502920" y="1828800"/>
             <a:ext cx="3337560" cy="64008"/>
           </a:xfrm>
           <a:prstGeom prst="rect">
@@ -8928,7 +9212,7 @@
         </p:nvSpPr>
         <p:spPr>
           <a:xfrm>
-            <a:off x="777240" y="2148840"/>
+            <a:off x="777240" y="2057400"/>
             <a:ext cx="2788920" cy="365760"/>
           </a:xfrm>
           <a:prstGeom prst="rect">
@@ -8967,7 +9251,7 @@
         </p:nvSpPr>
         <p:spPr>
           <a:xfrm>
-            <a:off x="777240" y="2514600"/>
+            <a:off x="777240" y="2423160"/>
             <a:ext cx="2788920" cy="548640"/>
           </a:xfrm>
           <a:prstGeom prst="rect">
@@ -8993,7 +9277,7 @@
                 </a:solidFill>
                 <a:latin typeface="Avenir Next"/>
               </a:rPr>
-              <a:t>Content assistance</a:t>
+              <a:t>Minds-assisted drafting</a:t>
             </a:r>
           </a:p>
         </p:txBody>
@@ -9006,7 +9290,7 @@
         </p:nvSpPr>
         <p:spPr>
           <a:xfrm>
-            <a:off x="777240" y="3063240"/>
+            <a:off x="777240" y="2971800"/>
             <a:ext cx="1042416" cy="292608"/>
           </a:xfrm>
           <a:prstGeom prst="roundRect">
@@ -9063,7 +9347,7 @@
         </p:nvSpPr>
         <p:spPr>
           <a:xfrm>
-            <a:off x="4343400" y="1920240"/>
+            <a:off x="4343400" y="1828800"/>
             <a:ext cx="3337560" cy="1554480"/>
           </a:xfrm>
           <a:prstGeom prst="roundRect">
@@ -9109,7 +9393,7 @@
         </p:nvSpPr>
         <p:spPr>
           <a:xfrm>
-            <a:off x="4343400" y="1920240"/>
+            <a:off x="4343400" y="1828800"/>
             <a:ext cx="3337560" cy="64008"/>
           </a:xfrm>
           <a:prstGeom prst="rect">
@@ -9153,7 +9437,7 @@
         </p:nvSpPr>
         <p:spPr>
           <a:xfrm>
-            <a:off x="4617720" y="2148840"/>
+            <a:off x="4617720" y="2057400"/>
             <a:ext cx="2788920" cy="365760"/>
           </a:xfrm>
           <a:prstGeom prst="rect">
@@ -9192,7 +9476,7 @@
         </p:nvSpPr>
         <p:spPr>
           <a:xfrm>
-            <a:off x="4617720" y="2514600"/>
+            <a:off x="4617720" y="2423160"/>
             <a:ext cx="2788920" cy="548640"/>
           </a:xfrm>
           <a:prstGeom prst="rect">
@@ -9218,7 +9502,7 @@
                 </a:solidFill>
                 <a:latin typeface="Avenir Next"/>
               </a:rPr>
-              <a:t>Single-session execution</a:t>
+              <a:t>One Mind, full session</a:t>
             </a:r>
           </a:p>
         </p:txBody>
@@ -9231,7 +9515,7 @@
         </p:nvSpPr>
         <p:spPr>
           <a:xfrm>
-            <a:off x="4617720" y="3063240"/>
+            <a:off x="4617720" y="2971800"/>
             <a:ext cx="1188720" cy="292608"/>
           </a:xfrm>
           <a:prstGeom prst="roundRect">
@@ -9288,7 +9572,7 @@
         </p:nvSpPr>
         <p:spPr>
           <a:xfrm>
-            <a:off x="8183879" y="1920240"/>
+            <a:off x="8183879" y="1828800"/>
             <a:ext cx="3337560" cy="1554480"/>
           </a:xfrm>
           <a:prstGeom prst="roundRect">
@@ -9334,7 +9618,7 @@
         </p:nvSpPr>
         <p:spPr>
           <a:xfrm>
-            <a:off x="8183879" y="1920240"/>
+            <a:off x="8183879" y="1828800"/>
             <a:ext cx="3337560" cy="64008"/>
           </a:xfrm>
           <a:prstGeom prst="rect">
@@ -9378,7 +9662,7 @@
         </p:nvSpPr>
         <p:spPr>
           <a:xfrm>
-            <a:off x="8458199" y="2148840"/>
+            <a:off x="8458199" y="2057400"/>
             <a:ext cx="2788920" cy="365760"/>
           </a:xfrm>
           <a:prstGeom prst="rect">
@@ -9417,7 +9701,7 @@
         </p:nvSpPr>
         <p:spPr>
           <a:xfrm>
-            <a:off x="8458199" y="2514600"/>
+            <a:off x="8458199" y="2423160"/>
             <a:ext cx="2788920" cy="548640"/>
           </a:xfrm>
           <a:prstGeom prst="rect">
@@ -9443,7 +9727,7 @@
                 </a:solidFill>
                 <a:latin typeface="Avenir Next"/>
               </a:rPr>
-              <a:t>Agent mode workspace</a:t>
+              <a:t>Multi-Mind workspace</a:t>
             </a:r>
           </a:p>
         </p:txBody>
@@ -9456,7 +9740,7 @@
         </p:nvSpPr>
         <p:spPr>
           <a:xfrm>
-            <a:off x="8458199" y="3063240"/>
+            <a:off x="8458199" y="2971800"/>
             <a:ext cx="1042416" cy="292608"/>
           </a:xfrm>
           <a:prstGeom prst="roundRect">
@@ -9513,8 +9797,8 @@
         </p:nvSpPr>
         <p:spPr>
           <a:xfrm>
-            <a:off x="502920" y="3886200"/>
-            <a:ext cx="11155680" cy="914400"/>
+            <a:off x="502920" y="3657600"/>
+            <a:ext cx="11155680" cy="822960"/>
           </a:xfrm>
           <a:prstGeom prst="rect">
             <a:avLst/>
@@ -9533,13 +9817,13 @@
               </a:lnSpc>
             </a:pPr>
             <a:r>
-              <a:rPr sz="2100" b="0" i="1">
+              <a:rPr sz="1900" b="0" i="1">
                 <a:solidFill>
                   <a:srgbClr val="5EE6C0"/>
                 </a:solidFill>
                 <a:latin typeface="Avenir Next"/>
               </a:rPr>
-              <a:t>Structured, actionable workflows → scalable user growth, real brand impact.</a:t>
+              <a:t>Not an integration bolted on after the fact — built on Minds from day one.</a:t>
             </a:r>
           </a:p>
         </p:txBody>
@@ -9552,8 +9836,8 @@
         </p:nvSpPr>
         <p:spPr>
           <a:xfrm>
-            <a:off x="502920" y="4892040"/>
-            <a:ext cx="11155680" cy="1188720"/>
+            <a:off x="502920" y="4434840"/>
+            <a:ext cx="11155680" cy="1280160"/>
           </a:xfrm>
           <a:prstGeom prst="rect">
             <a:avLst/>
@@ -9568,17 +9852,33 @@
           <a:p>
             <a:pPr algn="l">
               <a:lnSpc>
-                <a:spcPct val="115000"/>
-              </a:lnSpc>
-            </a:pPr>
-            <a:r>
-              <a:rPr sz="2600" b="1" i="0">
+                <a:spcPct val="120000"/>
+              </a:lnSpc>
+            </a:pPr>
+            <a:r>
+              <a:rPr sz="2500" b="1" i="0">
                 <a:solidFill>
                   <a:srgbClr val="F2F4F8"/>
                 </a:solidFill>
                 <a:latin typeface="Avenir Next"/>
               </a:rPr>
-              <a:t>We've built the first two stages. Now we're building the third.</a:t>
+              <a:t>What gets built on top of a platform is the best answer</a:t>
+            </a:r>
+          </a:p>
+          <a:p>
+            <a:pPr algn="l">
+              <a:lnSpc>
+                <a:spcPct val="120000"/>
+              </a:lnSpc>
+            </a:pPr>
+            <a:r>
+              <a:rPr sz="2500" b="1" i="0">
+                <a:solidFill>
+                  <a:srgbClr val="F2F4F8"/>
+                </a:solidFill>
+                <a:latin typeface="Avenir Next"/>
+              </a:rPr>
+              <a:t>a platform can have.</a:t>
             </a:r>
           </a:p>
         </p:txBody>
@@ -9591,8 +9891,8 @@
         </p:nvSpPr>
         <p:spPr>
           <a:xfrm>
-            <a:off x="502920" y="5806440"/>
-            <a:ext cx="5486400" cy="457200"/>
+            <a:off x="502920" y="5623560"/>
+            <a:ext cx="10515600" cy="548640"/>
           </a:xfrm>
           <a:prstGeom prst="rect">
             <a:avLst/>
@@ -9611,12 +9911,51 @@
               </a:lnSpc>
             </a:pPr>
             <a:r>
-              <a:rPr sz="1800" b="0" i="1">
+              <a:rPr sz="1550" b="0" i="1">
                 <a:solidFill>
                   <a:srgbClr val="A6AFC2"/>
                 </a:solidFill>
                 <a:latin typeface="Avenir Next"/>
               </a:rPr>
+              <a:t>We'd like to keep building that answer together — with your platform, and with your community.</a:t>
+            </a:r>
+          </a:p>
+        </p:txBody>
+      </p:sp>
+      <p:sp>
+        <p:nvSpPr>
+          <p:cNvPr id="24" name="TextBox 23"/>
+          <p:cNvSpPr txBox="1"/>
+          <p:nvPr/>
+        </p:nvSpPr>
+        <p:spPr>
+          <a:xfrm>
+            <a:off x="502920" y="6144768"/>
+            <a:ext cx="5486400" cy="365760"/>
+          </a:xfrm>
+          <a:prstGeom prst="rect">
+            <a:avLst/>
+          </a:prstGeom>
+          <a:noFill/>
+        </p:spPr>
+        <p:txBody>
+          <a:bodyPr wrap="square" anchor="t">
+            <a:spAutoFit/>
+          </a:bodyPr>
+          <a:lstStyle/>
+          <a:p>
+            <a:pPr algn="l">
+              <a:lnSpc>
+                <a:spcPct val="115000"/>
+              </a:lnSpc>
+            </a:pPr>
+            <a:r>
+              <a:rPr sz="1600" b="0" i="1">
+                <a:solidFill>
+                  <a:srgbClr val="A6AFC2"/>
+                </a:solidFill>
+                <a:latin typeface="Avenir Next"/>
+              </a:rPr>
               <a:t>Thank you.</a:t>
             </a:r>
           </a:p>
@@ -9624,7 +9963,7 @@
       </p:sp>
       <p:sp>
         <p:nvSpPr>
-          <p:cNvPr id="24" name="TextBox 23"/>
+          <p:cNvPr id="25" name="TextBox 24"/>
           <p:cNvSpPr txBox="1"/>
           <p:nvPr/>
         </p:nvSpPr>

</xml_diff>

<commit_message>
Restore "From Assistant to Autonomous" title, keep Minds-forward body
User confirmed: title works as-is (no need for "Built on Minds, From
Day One"), and the multi-agent/multi-Minds collaboration described in
Stage 3 is a confirmed feasible pattern on Minds, so that claim stands
unflagged.

Co-Authored-By: Claude Sonnet 5 <noreply@anthropic.com>
</commit_message>
<xml_diff>
--- a/presentations/launchminds-agent-evolution-2026-08/launchminds-deck.pptx
+++ b/presentations/launchminds-agent-evolution-2026-08/launchminds-deck.pptx
@@ -510,7 +510,7 @@
           <a:lstStyle/>
           <a:p>
             <a:r>
-              <a:t>Good [morning/afternoon] — I'm here to show you what we've built on top of Minds. Our name isn't an accident: Launch, plus Minds. We picked it because Minds is the foundation everything we do stands on — the same role Claude or GPT-4 plays for other companies, Minds plays for us. What you'll see today is proof of what that foundation makes possible, and where we want to take it next, together.</a:t>
+              <a:t>Good [morning/afternoon] — today I want to walk you through how LaunchMinds is evolving, from an assistant to something increasingly autonomous, and what that's been like to build on Minds. Our name isn't an accident: Launch, plus Minds. We picked it because Minds is the foundation everything we do stands on — the same role Claude or GPT-4 plays for other companies, Minds plays for us. What you'll see today is proof of what that foundation makes possible, and where we want to take it next, together.</a:t>
             </a:r>
           </a:p>
         </p:txBody>
@@ -4201,7 +4201,7 @@
                 </a:solidFill>
                 <a:latin typeface="Avenir Next"/>
               </a:rPr>
-              <a:t>Built on Minds,</a:t>
+              <a:t>From Assistant</a:t>
             </a:r>
           </a:p>
           <a:p>
@@ -4217,7 +4217,7 @@
                 </a:solidFill>
                 <a:latin typeface="Avenir Next"/>
               </a:rPr>
-              <a:t>From Day One</a:t>
+              <a:t>to Autonomous</a:t>
             </a:r>
           </a:p>
         </p:txBody>
@@ -4256,7 +4256,7 @@
                 </a:solidFill>
                 <a:latin typeface="Avenir Next"/>
               </a:rPr>
-              <a:t>Powered by Minds, built with Harness.</a:t>
+              <a:t>Built on Minds, from day one.</a:t>
             </a:r>
           </a:p>
         </p:txBody>

</xml_diff>

<commit_message>
Drop Sapien slide, soften Stage 3's multi-Minds claim, fix status wording
- Remove the Sapien collaboration slide (now 7 content slides, 8 total)
- Stage 3: multi-Minds coordination is no longer described as a fixed
  plan/execute/analyze/adjust pipeline of distinct model instances —
  the group's shape adapts to the campaign instead
- Stage 2 / closing: drop "in daily use"/"production" language since
  it's live internally but not yet public

Co-Authored-By: Claude Sonnet 5 <noreply@anthropic.com>
</commit_message>
<xml_diff>
--- a/presentations/launchminds-agent-evolution-2026-08/launchminds-deck.pptx
+++ b/presentations/launchminds-agent-evolution-2026-08/launchminds-deck.pptx
@@ -13,7 +13,6 @@
     <p:sldId id="261" r:id="rId13"/>
     <p:sldId id="262" r:id="rId14"/>
     <p:sldId id="263" r:id="rId15"/>
-    <p:sldId id="264" r:id="rId16"/>
   </p:sldIdLst>
   <p:sldSz cx="12191695" cy="6858000" type="screen4x3"/>
   <p:notesSz cx="6858000" cy="9144000"/>
@@ -860,7 +859,7 @@
           <a:lstStyle/>
           <a:p>
             <a:r>
-              <a:t>Stage two is what's running in production right now. One session, one Mind, handling registration, planning, and deployment end to end — no handoffs between tools. It runs through our internal skill system, which is essentially a set of structured capabilities we hand to Minds so it can act, not just suggest. This is the first stage where Minds does real work autonomously within a session, and it's in daily use today.</a:t>
+              <a:t>Stage two is what's live right now. One session, one Mind, handling registration, planning, and deployment end to end — no handoffs between tools. It runs through our internal skill system, which is essentially a set of structured capabilities we hand to Minds so it can act, not just suggest. This is the first stage where Minds does real work autonomously within a session.</a:t>
             </a:r>
           </a:p>
         </p:txBody>
@@ -930,7 +929,7 @@
           <a:lstStyle/>
           <a:p>
             <a:r>
-              <a:t>Stage three is our next milestone, and it's the part I think matters most for this room. We're building a per-project workspace where multiple Minds instances run side by side — one planning, one executing, one analyzing results, one adjusting the plan based on what it sees — coordinating with each other in a continuous loop. These aren't roles we're loosely calling 'Minds.' They're literal Minds models, each doing a distinct job, talking to each other. This is the clearest place you'll see what your platform makes possible when we push it toward real multi-agent coordination.</a:t>
+              <a:t>Stage three is our next milestone, and it's the part I think matters most for this room. We're building a per-project workspace where multiple Minds instances coordinate with each other — thinking through strategy, executing it, reading the results, and adjusting together. We're not locking that into a fixed pipeline of roles; the shape of that group adapts to what each campaign actually needs. This is the clearest place you'll see what your platform makes possible when we push it toward real multi-agent coordination.</a:t>
             </a:r>
           </a:p>
         </p:txBody>
@@ -1000,77 +999,7 @@
           <a:lstStyle/>
           <a:p>
             <a:r>
-              <a:t>One open thread, for full transparency: we're in early conversations with Sapien about the analyze step in that stage-three loop — whether their approach complements what Minds already gives us. To be clear, this is exploration, not a commitment. We want to be upfront about what's decided and what's still being evaluated, because that honesty is part of how we want to build this relationship with you.</a:t>
-            </a:r>
-          </a:p>
-        </p:txBody>
-      </p:sp>
-      <p:sp>
-        <p:nvSpPr>
-          <p:cNvPr id="4" name="Slide Number Placeholder 3"/>
-          <p:cNvSpPr>
-            <a:spLocks noGrp="1"/>
-          </p:cNvSpPr>
-          <p:nvPr>
-            <p:ph type="sldNum" idx="5" sz="quarter"/>
-          </p:nvPr>
-        </p:nvSpPr>
-        <p:spPr/>
-      </p:sp>
-    </p:spTree>
-  </p:cSld>
-  <p:clrMapOvr>
-    <a:masterClrMapping/>
-  </p:clrMapOvr>
-</p:notes>
-</file>
-
-<file path=ppt/notesSlides/notesSlide9.xml><?xml version="1.0" encoding="utf-8"?>
-<p:notes xmlns:a="http://schemas.openxmlformats.org/drawingml/2006/main" xmlns:p="http://schemas.openxmlformats.org/presentationml/2006/main" xmlns:r="http://schemas.openxmlformats.org/officeDocument/2006/relationships">
-  <p:cSld>
-    <p:spTree>
-      <p:nvGrpSpPr>
-        <p:cNvPr id="1" name=""/>
-        <p:cNvGrpSpPr/>
-        <p:nvPr/>
-      </p:nvGrpSpPr>
-      <p:grpSpPr>
-        <a:xfrm>
-          <a:off x="0" y="0"/>
-          <a:ext cx="0" cy="0"/>
-          <a:chOff x="0" y="0"/>
-          <a:chExt cx="0" cy="0"/>
-        </a:xfrm>
-      </p:grpSpPr>
-      <p:sp>
-        <p:nvSpPr>
-          <p:cNvPr id="2" name="Slide Image Placeholder 1"/>
-          <p:cNvSpPr>
-            <a:spLocks noGrp="1"/>
-          </p:cNvSpPr>
-          <p:nvPr>
-            <p:ph type="sldImg" idx="2"/>
-          </p:nvPr>
-        </p:nvSpPr>
-        <p:spPr/>
-      </p:sp>
-      <p:sp>
-        <p:nvSpPr>
-          <p:cNvPr id="3" name="Notes Placeholder 2"/>
-          <p:cNvSpPr>
-            <a:spLocks noGrp="1"/>
-          </p:cNvSpPr>
-          <p:nvPr>
-            <p:ph type="body" idx="3" sz="quarter"/>
-          </p:nvPr>
-        </p:nvSpPr>
-        <p:spPr/>
-        <p:txBody>
-          <a:bodyPr/>
-          <a:lstStyle/>
-          <a:p>
-            <a:r>
-              <a:t>So: two stages shipped and running, one stage actively in motion, built on Minds from day one — not as an integration bolted on after the fact, but as the foundation. We're showing you this because we think it's a good answer to the question every platform has to answer eventually: what gets built on top of us? We'd like to keep building that answer together — with your platform, and with your community. Thanks for the time.</a:t>
+              <a:t>So: two stages built and live today, one stage actively in motion, built on Minds from day one — not as an integration bolted on after the fact, but as the foundation. We're showing you this because we think it's a good answer to the question every platform has to answer eventually: what gets built on top of us? We'd like to keep building that answer together — with your platform, and with your community. Thanks for the time.</a:t>
             </a:r>
           </a:p>
         </p:txBody>
@@ -4523,7 +4452,7 @@
                 </a:solidFill>
                 <a:latin typeface="Avenir Next"/>
               </a:rPr>
-              <a:t>01 / 08</a:t>
+              <a:t>01 / 07</a:t>
             </a:r>
           </a:p>
         </p:txBody>
@@ -4864,7 +4793,7 @@
                 </a:solidFill>
                 <a:latin typeface="Avenir Next"/>
               </a:rPr>
-              <a:t>02 / 08</a:t>
+              <a:t>02 / 07</a:t>
             </a:r>
           </a:p>
         </p:txBody>
@@ -5605,7 +5534,7 @@
                 </a:solidFill>
                 <a:latin typeface="Avenir Next"/>
               </a:rPr>
-              <a:t>03 / 08</a:t>
+              <a:t>03 / 07</a:t>
             </a:r>
           </a:p>
         </p:txBody>
@@ -6423,7 +6352,7 @@
                 </a:solidFill>
                 <a:latin typeface="Avenir Next"/>
               </a:rPr>
-              <a:t>04 / 08</a:t>
+              <a:t>04 / 07</a:t>
             </a:r>
           </a:p>
         </p:txBody>
@@ -7178,7 +7107,7 @@
                 </a:solidFill>
                 <a:latin typeface="Avenir Next"/>
               </a:rPr>
-              <a:t>05 / 08</a:t>
+              <a:t>05 / 07</a:t>
             </a:r>
           </a:p>
         </p:txBody>
@@ -7707,7 +7636,7 @@
                 </a:solidFill>
                 <a:latin typeface="Avenir Next"/>
               </a:rPr>
-              <a:t>—  Minds doing real autonomous work within a session — live in production today</a:t>
+              <a:t>—  Minds doing real autonomous work within a session</a:t>
             </a:r>
           </a:p>
         </p:txBody>
@@ -7933,7 +7862,7 @@
                 </a:solidFill>
                 <a:latin typeface="Avenir Next"/>
               </a:rPr>
-              <a:t>06 / 08</a:t>
+              <a:t>06 / 07</a:t>
             </a:r>
           </a:p>
         </p:txBody>
@@ -8382,7 +8311,7 @@
                 </a:solidFill>
                 <a:latin typeface="Avenir Next"/>
               </a:rPr>
-              <a:t>A workspace of multiple Minds instances</a:t>
+              <a:t>A workspace of coordinating Minds</a:t>
             </a:r>
           </a:p>
         </p:txBody>
@@ -8424,7 +8353,7 @@
                 </a:solidFill>
                 <a:latin typeface="Avenir Next"/>
               </a:rPr>
-              <a:t>—  Per-project workspace: one Mind plans, one executes, one analyzes, one adjusts</a:t>
+              <a:t>—  Per-project workspace: multiple Minds instances coordinating</a:t>
             </a:r>
           </a:p>
           <a:p>
@@ -8443,7 +8372,7 @@
                 </a:solidFill>
                 <a:latin typeface="Avenir Next"/>
               </a:rPr>
-              <a:t>—  Not roles loosely called “Minds” — literal Minds models, coordinating in a loop</a:t>
+              <a:t>—  No fixed pipeline of roles — the group's shape adapts to what the campaign needs</a:t>
             </a:r>
           </a:p>
           <a:p>
@@ -8649,7 +8578,7 @@
                 </a:solidFill>
                 <a:latin typeface="Avenir Next"/>
               </a:rPr>
-              <a:t>EXPLORING</a:t>
+              <a:t>WHERE THIS GOES</a:t>
             </a:r>
           </a:p>
         </p:txBody>
@@ -8688,389 +8617,7 @@
                 </a:solidFill>
                 <a:latin typeface="Avenir Next"/>
               </a:rPr>
-              <a:t>07 / 08</a:t>
-            </a:r>
-          </a:p>
-        </p:txBody>
-      </p:sp>
-      <p:sp>
-        <p:nvSpPr>
-          <p:cNvPr id="5" name="TextBox 4"/>
-          <p:cNvSpPr txBox="1"/>
-          <p:nvPr/>
-        </p:nvSpPr>
-        <p:spPr>
-          <a:xfrm>
-            <a:off x="502920" y="960120"/>
-            <a:ext cx="10515600" cy="640080"/>
-          </a:xfrm>
-          <a:prstGeom prst="rect">
-            <a:avLst/>
-          </a:prstGeom>
-          <a:noFill/>
-        </p:spPr>
-        <p:txBody>
-          <a:bodyPr wrap="square" anchor="t">
-            <a:spAutoFit/>
-          </a:bodyPr>
-          <a:lstStyle/>
-          <a:p>
-            <a:pPr algn="l">
-              <a:lnSpc>
-                <a:spcPct val="115000"/>
-              </a:lnSpc>
-            </a:pPr>
-            <a:r>
-              <a:rPr sz="3600" b="1" i="0">
-                <a:solidFill>
-                  <a:srgbClr val="F2F4F8"/>
-                </a:solidFill>
-                <a:latin typeface="Avenir Next"/>
-              </a:rPr>
-              <a:t>One open thread: Sapien</a:t>
-            </a:r>
-          </a:p>
-        </p:txBody>
-      </p:sp>
-      <p:sp>
-        <p:nvSpPr>
-          <p:cNvPr id="6" name="Rounded Rectangle 5"/>
-          <p:cNvSpPr/>
-          <p:nvPr/>
-        </p:nvSpPr>
-        <p:spPr>
-          <a:xfrm>
-            <a:off x="502920" y="1783080"/>
-            <a:ext cx="3822191" cy="292608"/>
-          </a:xfrm>
-          <a:prstGeom prst="roundRect">
-            <a:avLst>
-              <a:gd name="adj" fmla="val 50000"/>
-            </a:avLst>
-          </a:prstGeom>
-          <a:solidFill>
-            <a:srgbClr val="0B0F1A"/>
-          </a:solidFill>
-          <a:ln w="12700">
-            <a:solidFill>
-              <a:srgbClr val="FFB46C"/>
-            </a:solidFill>
-          </a:ln>
-          <a:effectLst/>
-        </p:spPr>
-        <p:style>
-          <a:lnRef idx="1">
-            <a:schemeClr val="accent1"/>
-          </a:lnRef>
-          <a:fillRef idx="3">
-            <a:schemeClr val="accent1"/>
-          </a:fillRef>
-          <a:effectRef idx="2">
-            <a:schemeClr val="accent1"/>
-          </a:effectRef>
-          <a:fontRef idx="minor">
-            <a:schemeClr val="lt1"/>
-          </a:fontRef>
-        </p:style>
-        <p:txBody>
-          <a:bodyPr rtlCol="0" anchor="ctr" wrap="none" lIns="25400" rIns="25400" tIns="0" bIns="0"/>
-          <a:lstStyle/>
-          <a:p>
-            <a:pPr algn="ctr"/>
-            <a:r>
-              <a:rPr sz="1100" b="1">
-                <a:solidFill>
-                  <a:srgbClr val="FFB46C"/>
-                </a:solidFill>
-                <a:latin typeface="Avenir Next"/>
-              </a:rPr>
-              <a:t>EXPLORING · EARLY STAGE</a:t>
-            </a:r>
-          </a:p>
-        </p:txBody>
-      </p:sp>
-      <p:sp>
-        <p:nvSpPr>
-          <p:cNvPr id="7" name="TextBox 6"/>
-          <p:cNvSpPr txBox="1"/>
-          <p:nvPr/>
-        </p:nvSpPr>
-        <p:spPr>
-          <a:xfrm>
-            <a:off x="502920" y="2331720"/>
-            <a:ext cx="10515600" cy="2377440"/>
-          </a:xfrm>
-          <a:prstGeom prst="rect">
-            <a:avLst/>
-          </a:prstGeom>
-          <a:noFill/>
-        </p:spPr>
-        <p:txBody>
-          <a:bodyPr wrap="square">
-            <a:spAutoFit/>
-          </a:bodyPr>
-          <a:lstStyle/>
-          <a:p>
-            <a:pPr>
-              <a:lnSpc>
-                <a:spcPct val="120000"/>
-              </a:lnSpc>
-              <a:spcAft>
-                <a:spcPts val="1800"/>
-              </a:spcAft>
-            </a:pPr>
-            <a:r>
-              <a:rPr sz="1900">
-                <a:solidFill>
-                  <a:srgbClr val="F2F4F8"/>
-                </a:solidFill>
-                <a:latin typeface="Avenir Next"/>
-              </a:rPr>
-              <a:t>—  Early conversations, not finalized</a:t>
-            </a:r>
-          </a:p>
-          <a:p>
-            <a:pPr>
-              <a:lnSpc>
-                <a:spcPct val="120000"/>
-              </a:lnSpc>
-              <a:spcAft>
-                <a:spcPts val="1800"/>
-              </a:spcAft>
-            </a:pPr>
-            <a:r>
-              <a:rPr sz="1900">
-                <a:solidFill>
-                  <a:srgbClr val="F2F4F8"/>
-                </a:solidFill>
-                <a:latin typeface="Avenir Next"/>
-              </a:rPr>
-              <a:t>—  Potential collaboration on the “analyze” step of the Stage 3 loop</a:t>
-            </a:r>
-          </a:p>
-          <a:p>
-            <a:pPr>
-              <a:lnSpc>
-                <a:spcPct val="120000"/>
-              </a:lnSpc>
-              <a:spcAft>
-                <a:spcPts val="1800"/>
-              </a:spcAft>
-            </a:pPr>
-            <a:r>
-              <a:rPr sz="1900">
-                <a:solidFill>
-                  <a:srgbClr val="F2F4F8"/>
-                </a:solidFill>
-                <a:latin typeface="Avenir Next"/>
-              </a:rPr>
-              <a:t>—  Evaluating whether their approach complements what Minds already gives us</a:t>
-            </a:r>
-          </a:p>
-          <a:p>
-            <a:pPr>
-              <a:lnSpc>
-                <a:spcPct val="120000"/>
-              </a:lnSpc>
-              <a:spcAft>
-                <a:spcPts val="1800"/>
-              </a:spcAft>
-            </a:pPr>
-            <a:r>
-              <a:rPr sz="1900">
-                <a:solidFill>
-                  <a:srgbClr val="F2F4F8"/>
-                </a:solidFill>
-                <a:latin typeface="Avenir Next"/>
-              </a:rPr>
-              <a:t>—  Full transparency: exploration, not a commitment</a:t>
-            </a:r>
-          </a:p>
-        </p:txBody>
-      </p:sp>
-      <p:sp>
-        <p:nvSpPr>
-          <p:cNvPr id="8" name="TextBox 7"/>
-          <p:cNvSpPr txBox="1"/>
-          <p:nvPr/>
-        </p:nvSpPr>
-        <p:spPr>
-          <a:xfrm>
-            <a:off x="502920" y="6492240"/>
-            <a:ext cx="8229600" cy="274320"/>
-          </a:xfrm>
-          <a:prstGeom prst="rect">
-            <a:avLst/>
-          </a:prstGeom>
-          <a:noFill/>
-        </p:spPr>
-        <p:txBody>
-          <a:bodyPr wrap="square" anchor="t">
-            <a:spAutoFit/>
-          </a:bodyPr>
-          <a:lstStyle/>
-          <a:p>
-            <a:pPr algn="l">
-              <a:lnSpc>
-                <a:spcPct val="115000"/>
-              </a:lnSpc>
-            </a:pPr>
-            <a:r>
-              <a:rPr sz="950" b="0" i="0">
-                <a:solidFill>
-                  <a:srgbClr val="6B748C"/>
-                </a:solidFill>
-                <a:latin typeface="Avenir Next"/>
-              </a:rPr>
-              <a:t>LaunchMinds  ·  Built on Minds  ·  2026</a:t>
-            </a:r>
-          </a:p>
-        </p:txBody>
-      </p:sp>
-    </p:spTree>
-  </p:cSld>
-  <p:clrMapOvr>
-    <a:masterClrMapping/>
-  </p:clrMapOvr>
-</p:sld>
-</file>
-
-<file path=ppt/slides/slide9.xml><?xml version="1.0" encoding="utf-8"?>
-<p:sld xmlns:a="http://schemas.openxmlformats.org/drawingml/2006/main" xmlns:p="http://schemas.openxmlformats.org/presentationml/2006/main" xmlns:r="http://schemas.openxmlformats.org/officeDocument/2006/relationships">
-  <p:cSld>
-    <p:bg>
-      <p:bgPr>
-        <a:solidFill>
-          <a:srgbClr val="0B0F1A"/>
-        </a:solidFill>
-        <a:effectLst/>
-      </p:bgPr>
-    </p:bg>
-    <p:spTree>
-      <p:nvGrpSpPr>
-        <p:cNvPr id="1" name=""/>
-        <p:cNvGrpSpPr/>
-        <p:nvPr/>
-      </p:nvGrpSpPr>
-      <p:grpSpPr/>
-      <p:sp>
-        <p:nvSpPr>
-          <p:cNvPr id="2" name="Rectangle 1"/>
-          <p:cNvSpPr/>
-          <p:nvPr/>
-        </p:nvSpPr>
-        <p:spPr>
-          <a:xfrm>
-            <a:off x="502920" y="475488"/>
-            <a:ext cx="384048" cy="50292"/>
-          </a:xfrm>
-          <a:prstGeom prst="rect">
-            <a:avLst/>
-          </a:prstGeom>
-          <a:solidFill>
-            <a:srgbClr val="5EE6C0"/>
-          </a:solidFill>
-          <a:ln>
-            <a:noFill/>
-          </a:ln>
-          <a:effectLst/>
-        </p:spPr>
-        <p:style>
-          <a:lnRef idx="1">
-            <a:schemeClr val="accent1"/>
-          </a:lnRef>
-          <a:fillRef idx="3">
-            <a:schemeClr val="accent1"/>
-          </a:fillRef>
-          <a:effectRef idx="2">
-            <a:schemeClr val="accent1"/>
-          </a:effectRef>
-          <a:fontRef idx="minor">
-            <a:schemeClr val="lt1"/>
-          </a:fontRef>
-        </p:style>
-        <p:txBody>
-          <a:bodyPr rtlCol="0" anchor="ctr"/>
-          <a:lstStyle/>
-          <a:p>
-            <a:pPr algn="ctr"/>
-          </a:p>
-        </p:txBody>
-      </p:sp>
-      <p:sp>
-        <p:nvSpPr>
-          <p:cNvPr id="3" name="TextBox 2"/>
-          <p:cNvSpPr txBox="1"/>
-          <p:nvPr/>
-        </p:nvSpPr>
-        <p:spPr>
-          <a:xfrm>
-            <a:off x="502920" y="566928"/>
-            <a:ext cx="7315200" cy="365760"/>
-          </a:xfrm>
-          <a:prstGeom prst="rect">
-            <a:avLst/>
-          </a:prstGeom>
-          <a:noFill/>
-        </p:spPr>
-        <p:txBody>
-          <a:bodyPr wrap="square" anchor="t">
-            <a:spAutoFit/>
-          </a:bodyPr>
-          <a:lstStyle/>
-          <a:p>
-            <a:pPr algn="l">
-              <a:lnSpc>
-                <a:spcPct val="115000"/>
-              </a:lnSpc>
-            </a:pPr>
-            <a:r>
-              <a:rPr sz="1250" b="1" i="0">
-                <a:solidFill>
-                  <a:srgbClr val="A6AFC2"/>
-                </a:solidFill>
-                <a:latin typeface="Avenir Next"/>
-              </a:rPr>
-              <a:t>WHERE THIS GOES</a:t>
-            </a:r>
-          </a:p>
-        </p:txBody>
-      </p:sp>
-      <p:sp>
-        <p:nvSpPr>
-          <p:cNvPr id="4" name="TextBox 3"/>
-          <p:cNvSpPr txBox="1"/>
-          <p:nvPr/>
-        </p:nvSpPr>
-        <p:spPr>
-          <a:xfrm>
-            <a:off x="10881360" y="502920"/>
-            <a:ext cx="822960" cy="365760"/>
-          </a:xfrm>
-          <a:prstGeom prst="rect">
-            <a:avLst/>
-          </a:prstGeom>
-          <a:noFill/>
-        </p:spPr>
-        <p:txBody>
-          <a:bodyPr wrap="square" anchor="t">
-            <a:spAutoFit/>
-          </a:bodyPr>
-          <a:lstStyle/>
-          <a:p>
-            <a:pPr algn="r">
-              <a:lnSpc>
-                <a:spcPct val="115000"/>
-              </a:lnSpc>
-            </a:pPr>
-            <a:r>
-              <a:rPr sz="1250" b="0" i="0">
-                <a:solidFill>
-                  <a:srgbClr val="6B748C"/>
-                </a:solidFill>
-                <a:latin typeface="Avenir Next"/>
-              </a:rPr>
-              <a:t>08 / 08</a:t>
+              <a:t>07 / 07</a:t>
             </a:r>
           </a:p>
         </p:txBody>

</xml_diff>